<commit_message>
initial aws data engineering
</commit_message>
<xml_diff>
--- a/lecture_notes/section_3_introduction_to_amazon_aws/3-1-Introduction to Cloud Computing and Amazon AWS.pptx
+++ b/lecture_notes/section_3_introduction_to_amazon_aws/3-1-Introduction to Cloud Computing and Amazon AWS.pptx
@@ -251,36 +251,6 @@
         <pc:sldMkLst>
           <pc:docMk/>
           <pc:sldMk cId="2297456757" sldId="483"/>
-        </pc:sldMkLst>
-      </pc:sldChg>
-    </pc:docChg>
-  </pc:docChgLst>
-  <pc:docChgLst>
-    <pc:chgData name="Mohammed Fasha" userId="cc64f42d-a1a6-4f08-b97b-0c37f877119f" providerId="ADAL" clId="{4C71ED24-115E-432D-933D-C801DA3E52F1}"/>
-    <pc:docChg chg="delSld">
-      <pc:chgData name="Mohammed Fasha" userId="cc64f42d-a1a6-4f08-b97b-0c37f877119f" providerId="ADAL" clId="{4C71ED24-115E-432D-933D-C801DA3E52F1}" dt="2024-12-29T03:12:49.974" v="2" actId="47"/>
-      <pc:docMkLst>
-        <pc:docMk/>
-      </pc:docMkLst>
-      <pc:sldChg chg="del">
-        <pc:chgData name="Mohammed Fasha" userId="cc64f42d-a1a6-4f08-b97b-0c37f877119f" providerId="ADAL" clId="{4C71ED24-115E-432D-933D-C801DA3E52F1}" dt="2024-12-29T03:12:48.360" v="0" actId="47"/>
-        <pc:sldMkLst>
-          <pc:docMk/>
-          <pc:sldMk cId="2341000601" sldId="701"/>
-        </pc:sldMkLst>
-      </pc:sldChg>
-      <pc:sldChg chg="del">
-        <pc:chgData name="Mohammed Fasha" userId="cc64f42d-a1a6-4f08-b97b-0c37f877119f" providerId="ADAL" clId="{4C71ED24-115E-432D-933D-C801DA3E52F1}" dt="2024-12-29T03:12:49.133" v="1" actId="47"/>
-        <pc:sldMkLst>
-          <pc:docMk/>
-          <pc:sldMk cId="3519698944" sldId="702"/>
-        </pc:sldMkLst>
-      </pc:sldChg>
-      <pc:sldChg chg="del">
-        <pc:chgData name="Mohammed Fasha" userId="cc64f42d-a1a6-4f08-b97b-0c37f877119f" providerId="ADAL" clId="{4C71ED24-115E-432D-933D-C801DA3E52F1}" dt="2024-12-29T03:12:49.974" v="2" actId="47"/>
-        <pc:sldMkLst>
-          <pc:docMk/>
-          <pc:sldMk cId="3934257344" sldId="703"/>
         </pc:sldMkLst>
       </pc:sldChg>
     </pc:docChg>
@@ -575,6 +545,36 @@
           </pc:spChg>
         </pc:sldLayoutChg>
       </pc:sldMasterChg>
+    </pc:docChg>
+  </pc:docChgLst>
+  <pc:docChgLst>
+    <pc:chgData name="Mohammed Fasha" userId="cc64f42d-a1a6-4f08-b97b-0c37f877119f" providerId="ADAL" clId="{4C71ED24-115E-432D-933D-C801DA3E52F1}"/>
+    <pc:docChg chg="delSld">
+      <pc:chgData name="Mohammed Fasha" userId="cc64f42d-a1a6-4f08-b97b-0c37f877119f" providerId="ADAL" clId="{4C71ED24-115E-432D-933D-C801DA3E52F1}" dt="2024-12-29T03:12:49.974" v="2" actId="47"/>
+      <pc:docMkLst>
+        <pc:docMk/>
+      </pc:docMkLst>
+      <pc:sldChg chg="del">
+        <pc:chgData name="Mohammed Fasha" userId="cc64f42d-a1a6-4f08-b97b-0c37f877119f" providerId="ADAL" clId="{4C71ED24-115E-432D-933D-C801DA3E52F1}" dt="2024-12-29T03:12:48.360" v="0" actId="47"/>
+        <pc:sldMkLst>
+          <pc:docMk/>
+          <pc:sldMk cId="2341000601" sldId="701"/>
+        </pc:sldMkLst>
+      </pc:sldChg>
+      <pc:sldChg chg="del">
+        <pc:chgData name="Mohammed Fasha" userId="cc64f42d-a1a6-4f08-b97b-0c37f877119f" providerId="ADAL" clId="{4C71ED24-115E-432D-933D-C801DA3E52F1}" dt="2024-12-29T03:12:49.133" v="1" actId="47"/>
+        <pc:sldMkLst>
+          <pc:docMk/>
+          <pc:sldMk cId="3519698944" sldId="702"/>
+        </pc:sldMkLst>
+      </pc:sldChg>
+      <pc:sldChg chg="del">
+        <pc:chgData name="Mohammed Fasha" userId="cc64f42d-a1a6-4f08-b97b-0c37f877119f" providerId="ADAL" clId="{4C71ED24-115E-432D-933D-C801DA3E52F1}" dt="2024-12-29T03:12:49.974" v="2" actId="47"/>
+        <pc:sldMkLst>
+          <pc:docMk/>
+          <pc:sldMk cId="3934257344" sldId="703"/>
+        </pc:sldMkLst>
+      </pc:sldChg>
     </pc:docChg>
   </pc:docChgLst>
   <pc:docChgLst>
@@ -5701,6 +5701,30 @@
       </pc:sldMasterChg>
     </pc:docChg>
   </pc:docChgLst>
+  <pc:docChgLst>
+    <pc:chgData name="Mohammed Fasha" userId="cc64f42d-a1a6-4f08-b97b-0c37f877119f" providerId="ADAL" clId="{C4E19E38-7064-4221-B9EB-EDF8265691F0}"/>
+    <pc:docChg chg="modSld">
+      <pc:chgData name="Mohammed Fasha" userId="cc64f42d-a1a6-4f08-b97b-0c37f877119f" providerId="ADAL" clId="{C4E19E38-7064-4221-B9EB-EDF8265691F0}" dt="2025-04-20T19:30:54.966" v="2" actId="20577"/>
+      <pc:docMkLst>
+        <pc:docMk/>
+      </pc:docMkLst>
+      <pc:sldChg chg="modSp mod">
+        <pc:chgData name="Mohammed Fasha" userId="cc64f42d-a1a6-4f08-b97b-0c37f877119f" providerId="ADAL" clId="{C4E19E38-7064-4221-B9EB-EDF8265691F0}" dt="2025-04-20T19:30:54.966" v="2" actId="20577"/>
+        <pc:sldMkLst>
+          <pc:docMk/>
+          <pc:sldMk cId="2297456757" sldId="483"/>
+        </pc:sldMkLst>
+        <pc:spChg chg="mod">
+          <ac:chgData name="Mohammed Fasha" userId="cc64f42d-a1a6-4f08-b97b-0c37f877119f" providerId="ADAL" clId="{C4E19E38-7064-4221-B9EB-EDF8265691F0}" dt="2025-04-20T19:30:54.966" v="2" actId="20577"/>
+          <ac:spMkLst>
+            <pc:docMk/>
+            <pc:sldMk cId="2297456757" sldId="483"/>
+            <ac:spMk id="5" creationId="{89403830-E271-DAA0-8838-E295A84A8B5B}"/>
+          </ac:spMkLst>
+        </pc:spChg>
+      </pc:sldChg>
+    </pc:docChg>
+  </pc:docChgLst>
 </pc:chgInfo>
 </file>
 
@@ -10104,8 +10128,12 @@
           <a:lstStyle/>
           <a:p>
             <a:r>
+              <a:rPr lang="en-US" sz="3200" b="0"/>
+              <a:t>Introduction to Cloud </a:t>
+            </a:r>
+            <a:r>
               <a:rPr lang="en-US" sz="3200" b="0" dirty="0"/>
-              <a:t>Introduction Cloud Computing and Amazon AWS</a:t>
+              <a:t>Computing and Amazon AWS</a:t>
             </a:r>
           </a:p>
           <a:p>
@@ -29537,14 +29565,14 @@
             </a:ln>
             <a:extLst>
               <a:ext uri="{909E8E84-426E-40dd-AFC4-6F175D3DCCD1}">
-                <a14:hiddenFill xmlns:a14="http://schemas.microsoft.com/office/drawing/2010/main" xmlns="">
+                <a14:hiddenFill xmlns="" xmlns:a14="http://schemas.microsoft.com/office/drawing/2010/main">
                   <a:solidFill>
                     <a:srgbClr val="FFFFFF"/>
                   </a:solidFill>
                 </a14:hiddenFill>
               </a:ext>
               <a:ext uri="{91240B29-F687-4f45-9708-019B960494DF}">
-                <a14:hiddenLine xmlns:a14="http://schemas.microsoft.com/office/drawing/2010/main" xmlns="" w="9525">
+                <a14:hiddenLine xmlns="" xmlns:a14="http://schemas.microsoft.com/office/drawing/2010/main" w="9525">
                   <a:solidFill>
                     <a:srgbClr val="000000"/>
                   </a:solidFill>
@@ -29584,14 +29612,14 @@
             </a:ln>
             <a:extLst>
               <a:ext uri="{909E8E84-426E-40dd-AFC4-6F175D3DCCD1}">
-                <a14:hiddenFill xmlns:a14="http://schemas.microsoft.com/office/drawing/2010/main" xmlns="">
+                <a14:hiddenFill xmlns="" xmlns:a14="http://schemas.microsoft.com/office/drawing/2010/main">
                   <a:solidFill>
                     <a:srgbClr val="FFFFFF"/>
                   </a:solidFill>
                 </a14:hiddenFill>
               </a:ext>
               <a:ext uri="{91240B29-F687-4f45-9708-019B960494DF}">
-                <a14:hiddenLine xmlns:a14="http://schemas.microsoft.com/office/drawing/2010/main" xmlns="" w="9525">
+                <a14:hiddenLine xmlns="" xmlns:a14="http://schemas.microsoft.com/office/drawing/2010/main" w="9525">
                   <a:solidFill>
                     <a:srgbClr val="000000"/>
                   </a:solidFill>
@@ -29771,14 +29799,14 @@
             </a:ln>
             <a:extLst>
               <a:ext uri="{909E8E84-426E-40dd-AFC4-6F175D3DCCD1}">
-                <a14:hiddenFill xmlns:a14="http://schemas.microsoft.com/office/drawing/2010/main" xmlns="">
+                <a14:hiddenFill xmlns="" xmlns:a14="http://schemas.microsoft.com/office/drawing/2010/main">
                   <a:solidFill>
                     <a:srgbClr val="FFFFFF"/>
                   </a:solidFill>
                 </a14:hiddenFill>
               </a:ext>
               <a:ext uri="{91240B29-F687-4f45-9708-019B960494DF}">
-                <a14:hiddenLine xmlns:a14="http://schemas.microsoft.com/office/drawing/2010/main" xmlns="" w="9525">
+                <a14:hiddenLine xmlns="" xmlns:a14="http://schemas.microsoft.com/office/drawing/2010/main" w="9525">
                   <a:solidFill>
                     <a:srgbClr val="000000"/>
                   </a:solidFill>
@@ -29818,14 +29846,14 @@
             </a:ln>
             <a:extLst>
               <a:ext uri="{909E8E84-426E-40dd-AFC4-6F175D3DCCD1}">
-                <a14:hiddenFill xmlns:a14="http://schemas.microsoft.com/office/drawing/2010/main" xmlns="">
+                <a14:hiddenFill xmlns="" xmlns:a14="http://schemas.microsoft.com/office/drawing/2010/main">
                   <a:solidFill>
                     <a:srgbClr val="FFFFFF"/>
                   </a:solidFill>
                 </a14:hiddenFill>
               </a:ext>
               <a:ext uri="{91240B29-F687-4f45-9708-019B960494DF}">
-                <a14:hiddenLine xmlns:a14="http://schemas.microsoft.com/office/drawing/2010/main" xmlns="" w="9525">
+                <a14:hiddenLine xmlns="" xmlns:a14="http://schemas.microsoft.com/office/drawing/2010/main" w="9525">
                   <a:solidFill>
                     <a:srgbClr val="000000"/>
                   </a:solidFill>
@@ -29989,14 +30017,14 @@
             </a:ln>
             <a:extLst>
               <a:ext uri="{909E8E84-426E-40dd-AFC4-6F175D3DCCD1}">
-                <a14:hiddenFill xmlns:a14="http://schemas.microsoft.com/office/drawing/2010/main" xmlns="">
+                <a14:hiddenFill xmlns="" xmlns:a14="http://schemas.microsoft.com/office/drawing/2010/main">
                   <a:solidFill>
                     <a:srgbClr val="FFFFFF"/>
                   </a:solidFill>
                 </a14:hiddenFill>
               </a:ext>
               <a:ext uri="{91240B29-F687-4f45-9708-019B960494DF}">
-                <a14:hiddenLine xmlns:a14="http://schemas.microsoft.com/office/drawing/2010/main" xmlns="" w="9525">
+                <a14:hiddenLine xmlns="" xmlns:a14="http://schemas.microsoft.com/office/drawing/2010/main" w="9525">
                   <a:solidFill>
                     <a:srgbClr val="000000"/>
                   </a:solidFill>
@@ -30225,14 +30253,14 @@
             </a:ln>
             <a:extLst>
               <a:ext uri="{909E8E84-426E-40dd-AFC4-6F175D3DCCD1}">
-                <a14:hiddenFill xmlns:a14="http://schemas.microsoft.com/office/drawing/2010/main" xmlns="">
+                <a14:hiddenFill xmlns="" xmlns:a14="http://schemas.microsoft.com/office/drawing/2010/main">
                   <a:solidFill>
                     <a:srgbClr val="FFFFFF"/>
                   </a:solidFill>
                 </a14:hiddenFill>
               </a:ext>
               <a:ext uri="{91240B29-F687-4f45-9708-019B960494DF}">
-                <a14:hiddenLine xmlns:a14="http://schemas.microsoft.com/office/drawing/2010/main" xmlns="" w="9525">
+                <a14:hiddenLine xmlns="" xmlns:a14="http://schemas.microsoft.com/office/drawing/2010/main" w="9525">
                   <a:solidFill>
                     <a:srgbClr val="000000"/>
                   </a:solidFill>
@@ -30539,14 +30567,14 @@
             </a:ln>
             <a:extLst>
               <a:ext uri="{909E8E84-426E-40dd-AFC4-6F175D3DCCD1}">
-                <a14:hiddenFill xmlns:a14="http://schemas.microsoft.com/office/drawing/2010/main" xmlns="">
+                <a14:hiddenFill xmlns="" xmlns:a14="http://schemas.microsoft.com/office/drawing/2010/main">
                   <a:solidFill>
                     <a:srgbClr val="FFFFFF"/>
                   </a:solidFill>
                 </a14:hiddenFill>
               </a:ext>
               <a:ext uri="{91240B29-F687-4f45-9708-019B960494DF}">
-                <a14:hiddenLine xmlns:a14="http://schemas.microsoft.com/office/drawing/2010/main" xmlns="" w="9525">
+                <a14:hiddenLine xmlns="" xmlns:a14="http://schemas.microsoft.com/office/drawing/2010/main" w="9525">
                   <a:solidFill>
                     <a:srgbClr val="000000"/>
                   </a:solidFill>
@@ -30726,14 +30754,14 @@
             </a:ln>
             <a:extLst>
               <a:ext uri="{909E8E84-426E-40dd-AFC4-6F175D3DCCD1}">
-                <a14:hiddenFill xmlns:a14="http://schemas.microsoft.com/office/drawing/2010/main" xmlns="">
+                <a14:hiddenFill xmlns="" xmlns:a14="http://schemas.microsoft.com/office/drawing/2010/main">
                   <a:solidFill>
                     <a:srgbClr val="FFFFFF"/>
                   </a:solidFill>
                 </a14:hiddenFill>
               </a:ext>
               <a:ext uri="{91240B29-F687-4f45-9708-019B960494DF}">
-                <a14:hiddenLine xmlns:a14="http://schemas.microsoft.com/office/drawing/2010/main" xmlns="" w="9525">
+                <a14:hiddenLine xmlns="" xmlns:a14="http://schemas.microsoft.com/office/drawing/2010/main" w="9525">
                   <a:solidFill>
                     <a:srgbClr val="000000"/>
                   </a:solidFill>
@@ -30773,14 +30801,14 @@
             </a:ln>
             <a:extLst>
               <a:ext uri="{909E8E84-426E-40dd-AFC4-6F175D3DCCD1}">
-                <a14:hiddenFill xmlns:a14="http://schemas.microsoft.com/office/drawing/2010/main" xmlns="">
+                <a14:hiddenFill xmlns="" xmlns:a14="http://schemas.microsoft.com/office/drawing/2010/main">
                   <a:solidFill>
                     <a:srgbClr val="FFFFFF"/>
                   </a:solidFill>
                 </a14:hiddenFill>
               </a:ext>
               <a:ext uri="{91240B29-F687-4f45-9708-019B960494DF}">
-                <a14:hiddenLine xmlns:a14="http://schemas.microsoft.com/office/drawing/2010/main" xmlns="" w="9525">
+                <a14:hiddenLine xmlns="" xmlns:a14="http://schemas.microsoft.com/office/drawing/2010/main" w="9525">
                   <a:solidFill>
                     <a:srgbClr val="000000"/>
                   </a:solidFill>
@@ -30960,14 +30988,14 @@
             </a:ln>
             <a:extLst>
               <a:ext uri="{909E8E84-426E-40dd-AFC4-6F175D3DCCD1}">
-                <a14:hiddenFill xmlns:a14="http://schemas.microsoft.com/office/drawing/2010/main" xmlns="">
+                <a14:hiddenFill xmlns="" xmlns:a14="http://schemas.microsoft.com/office/drawing/2010/main">
                   <a:solidFill>
                     <a:srgbClr val="FFFFFF"/>
                   </a:solidFill>
                 </a14:hiddenFill>
               </a:ext>
               <a:ext uri="{91240B29-F687-4f45-9708-019B960494DF}">
-                <a14:hiddenLine xmlns:a14="http://schemas.microsoft.com/office/drawing/2010/main" xmlns="" w="9525">
+                <a14:hiddenLine xmlns="" xmlns:a14="http://schemas.microsoft.com/office/drawing/2010/main" w="9525">
                   <a:solidFill>
                     <a:srgbClr val="000000"/>
                   </a:solidFill>
@@ -31007,14 +31035,14 @@
             </a:ln>
             <a:extLst>
               <a:ext uri="{909E8E84-426E-40dd-AFC4-6F175D3DCCD1}">
-                <a14:hiddenFill xmlns:a14="http://schemas.microsoft.com/office/drawing/2010/main" xmlns="">
+                <a14:hiddenFill xmlns="" xmlns:a14="http://schemas.microsoft.com/office/drawing/2010/main">
                   <a:solidFill>
                     <a:srgbClr val="FFFFFF"/>
                   </a:solidFill>
                 </a14:hiddenFill>
               </a:ext>
               <a:ext uri="{91240B29-F687-4f45-9708-019B960494DF}">
-                <a14:hiddenLine xmlns:a14="http://schemas.microsoft.com/office/drawing/2010/main" xmlns="" w="9525">
+                <a14:hiddenLine xmlns="" xmlns:a14="http://schemas.microsoft.com/office/drawing/2010/main" w="9525">
                   <a:solidFill>
                     <a:srgbClr val="000000"/>
                   </a:solidFill>
@@ -31468,14 +31496,14 @@
             </a:ln>
             <a:extLst>
               <a:ext uri="{909E8E84-426E-40dd-AFC4-6F175D3DCCD1}">
-                <a14:hiddenFill xmlns:a14="http://schemas.microsoft.com/office/drawing/2010/main" xmlns="">
+                <a14:hiddenFill xmlns="" xmlns:a14="http://schemas.microsoft.com/office/drawing/2010/main">
                   <a:solidFill>
                     <a:srgbClr val="FFFFFF"/>
                   </a:solidFill>
                 </a14:hiddenFill>
               </a:ext>
               <a:ext uri="{91240B29-F687-4f45-9708-019B960494DF}">
-                <a14:hiddenLine xmlns:a14="http://schemas.microsoft.com/office/drawing/2010/main" xmlns="" w="9525">
+                <a14:hiddenLine xmlns="" xmlns:a14="http://schemas.microsoft.com/office/drawing/2010/main" w="9525">
                   <a:solidFill>
                     <a:srgbClr val="000000"/>
                   </a:solidFill>

</xml_diff>